<commit_message>
Kit Essencial: três vídeos de demonstração narrados (mp4 + srt), gerador de vídeos, pacote de entrega v1
Co-Authored-By: Claude Fable 5.1 <noreply@anthropic.com>
Claude-Session: https://claude.ai/code/session_0146uBo6FVJ2cyEehyP8rK61
</commit_message>
<xml_diff>
--- a/projetos/gestao-ia-planilhas/produto/kit-essencial/entrega/06-modelo-apresentacao-8-slides.pptx
+++ b/projetos/gestao-ia-planilhas/produto/kit-essencial/entrega/06-modelo-apresentacao-8-slides.pptx
@@ -3441,7 +3441,7 @@
         </p:nvSpPr>
         <p:spPr>
           <a:xfrm>
-            <a:off x="4114800" y="2395728"/>
+            <a:off x="868680" y="2395728"/>
             <a:ext cx="1280160" cy="228600"/>
           </a:xfrm>
           <a:prstGeom prst="rect">
@@ -3454,7 +3454,7 @@
           <a:bodyPr wrap="square" lIns="0" tIns="0" rIns="0" bIns="0" rtlCol="0" anchor="ctr"/>
           <a:lstStyle/>
           <a:p>
-            <a:pPr algn="r" indent="0" marL="0">
+            <a:pPr indent="0" marL="0">
               <a:buNone/>
             </a:pPr>
             <a:r>

</xml_diff>